<commit_message>
Ajustes documentación, organización de archivos y cambios en la presentación
</commit_message>
<xml_diff>
--- a/docs/PRESENTACION-SLIDES.pptx
+++ b/docs/PRESENTACION-SLIDES.pptx
@@ -5,7 +5,7 @@
     <p:sldMasterId id="2147483648" r:id="rId1"/>
   </p:sldMasterIdLst>
   <p:notesMasterIdLst>
-    <p:notesMasterId r:id="rId18"/>
+    <p:notesMasterId r:id="rId19"/>
   </p:notesMasterIdLst>
   <p:sldIdLst>
     <p:sldId id="256" r:id="rId2"/>
@@ -16,15 +16,15 @@
     <p:sldId id="261" r:id="rId7"/>
     <p:sldId id="262" r:id="rId8"/>
     <p:sldId id="263" r:id="rId9"/>
-    <p:sldId id="272" r:id="rId23"/>
-    <p:sldId id="264" r:id="rId10"/>
-    <p:sldId id="265" r:id="rId11"/>
-    <p:sldId id="266" r:id="rId12"/>
-    <p:sldId id="267" r:id="rId13"/>
-    <p:sldId id="268" r:id="rId14"/>
-    <p:sldId id="269" r:id="rId15"/>
-    <p:sldId id="270" r:id="rId16"/>
-    <p:sldId id="271" r:id="rId17"/>
+    <p:sldId id="272" r:id="rId10"/>
+    <p:sldId id="264" r:id="rId11"/>
+    <p:sldId id="265" r:id="rId12"/>
+    <p:sldId id="266" r:id="rId13"/>
+    <p:sldId id="267" r:id="rId14"/>
+    <p:sldId id="268" r:id="rId15"/>
+    <p:sldId id="269" r:id="rId16"/>
+    <p:sldId id="270" r:id="rId17"/>
+    <p:sldId id="271" r:id="rId18"/>
   </p:sldIdLst>
   <p:sldSz cx="12192000" cy="6858000"/>
   <p:notesSz cx="6858000" cy="9144000"/>
@@ -1566,7 +1566,7 @@
           <a:p>
             <a:fld id="{5BCAD085-E8A6-8845-BD4E-CB4CCA059FC4}" type="datetimeFigureOut">
               <a:rPr lang="en-US" smtClean="0"/>
-              <a:t>7/10/2026</a:t>
+              <a:t>7/23/2026</a:t>
             </a:fld>
             <a:endParaRPr lang="en-US"/>
           </a:p>
@@ -1734,7 +1734,7 @@
           <a:p>
             <a:fld id="{5BCAD085-E8A6-8845-BD4E-CB4CCA059FC4}" type="datetimeFigureOut">
               <a:rPr lang="en-US" smtClean="0"/>
-              <a:t>7/10/2026</a:t>
+              <a:t>7/23/2026</a:t>
             </a:fld>
             <a:endParaRPr lang="en-US"/>
           </a:p>
@@ -1912,7 +1912,7 @@
           <a:p>
             <a:fld id="{5BCAD085-E8A6-8845-BD4E-CB4CCA059FC4}" type="datetimeFigureOut">
               <a:rPr lang="en-US" smtClean="0"/>
-              <a:t>7/10/2026</a:t>
+              <a:t>7/23/2026</a:t>
             </a:fld>
             <a:endParaRPr lang="en-US"/>
           </a:p>
@@ -2080,7 +2080,7 @@
           <a:p>
             <a:fld id="{5BCAD085-E8A6-8845-BD4E-CB4CCA059FC4}" type="datetimeFigureOut">
               <a:rPr lang="en-US" smtClean="0"/>
-              <a:t>7/10/2026</a:t>
+              <a:t>7/23/2026</a:t>
             </a:fld>
             <a:endParaRPr lang="en-US"/>
           </a:p>
@@ -2325,7 +2325,7 @@
           <a:p>
             <a:fld id="{5BCAD085-E8A6-8845-BD4E-CB4CCA059FC4}" type="datetimeFigureOut">
               <a:rPr lang="en-US" smtClean="0"/>
-              <a:t>7/10/2026</a:t>
+              <a:t>7/23/2026</a:t>
             </a:fld>
             <a:endParaRPr lang="en-US"/>
           </a:p>
@@ -2610,7 +2610,7 @@
           <a:p>
             <a:fld id="{5BCAD085-E8A6-8845-BD4E-CB4CCA059FC4}" type="datetimeFigureOut">
               <a:rPr lang="en-US" smtClean="0"/>
-              <a:t>7/10/2026</a:t>
+              <a:t>7/23/2026</a:t>
             </a:fld>
             <a:endParaRPr lang="en-US"/>
           </a:p>
@@ -3029,7 +3029,7 @@
           <a:p>
             <a:fld id="{5BCAD085-E8A6-8845-BD4E-CB4CCA059FC4}" type="datetimeFigureOut">
               <a:rPr lang="en-US" smtClean="0"/>
-              <a:t>7/10/2026</a:t>
+              <a:t>7/23/2026</a:t>
             </a:fld>
             <a:endParaRPr lang="en-US"/>
           </a:p>
@@ -3146,7 +3146,7 @@
           <a:p>
             <a:fld id="{5BCAD085-E8A6-8845-BD4E-CB4CCA059FC4}" type="datetimeFigureOut">
               <a:rPr lang="en-US" smtClean="0"/>
-              <a:t>7/10/2026</a:t>
+              <a:t>7/23/2026</a:t>
             </a:fld>
             <a:endParaRPr lang="en-US"/>
           </a:p>
@@ -3241,7 +3241,7 @@
           <a:p>
             <a:fld id="{5BCAD085-E8A6-8845-BD4E-CB4CCA059FC4}" type="datetimeFigureOut">
               <a:rPr lang="en-US" smtClean="0"/>
-              <a:t>7/10/2026</a:t>
+              <a:t>7/23/2026</a:t>
             </a:fld>
             <a:endParaRPr lang="en-US"/>
           </a:p>
@@ -3516,7 +3516,7 @@
           <a:p>
             <a:fld id="{5BCAD085-E8A6-8845-BD4E-CB4CCA059FC4}" type="datetimeFigureOut">
               <a:rPr lang="en-US" smtClean="0"/>
-              <a:t>7/10/2026</a:t>
+              <a:t>7/23/2026</a:t>
             </a:fld>
             <a:endParaRPr lang="en-US"/>
           </a:p>
@@ -3768,7 +3768,7 @@
           <a:p>
             <a:fld id="{5BCAD085-E8A6-8845-BD4E-CB4CCA059FC4}" type="datetimeFigureOut">
               <a:rPr lang="en-US" smtClean="0"/>
-              <a:t>7/10/2026</a:t>
+              <a:t>7/23/2026</a:t>
             </a:fld>
             <a:endParaRPr lang="en-US"/>
           </a:p>
@@ -3979,7 +3979,7 @@
           <a:p>
             <a:fld id="{5BCAD085-E8A6-8845-BD4E-CB4CCA059FC4}" type="datetimeFigureOut">
               <a:rPr lang="en-US" smtClean="0"/>
-              <a:t>7/10/2026</a:t>
+              <a:t>7/23/2026</a:t>
             </a:fld>
             <a:endParaRPr lang="en-US"/>
           </a:p>
@@ -5449,7 +5449,7 @@
         <p:spPr>
           <a:xfrm>
             <a:off x="1188720" y="2157795"/>
-            <a:ext cx="11064240" cy="3170099"/>
+            <a:ext cx="11064240" cy="4555093"/>
           </a:xfrm>
           <a:prstGeom prst="rect">
             <a:avLst/>
@@ -5803,6 +5803,50 @@
               </a:rPr>
               <a:t>)</a:t>
             </a:r>
+            <a:endParaRPr lang="es-ES" sz="2000" dirty="0">
+              <a:solidFill>
+                <a:srgbClr val="222222"/>
+              </a:solidFill>
+            </a:endParaRPr>
+          </a:p>
+          <a:p>
+            <a:pPr>
+              <a:spcAft>
+                <a:spcPts val="1200"/>
+              </a:spcAft>
+            </a:pPr>
+            <a:endParaRPr lang="es-ES" sz="2000" dirty="0">
+              <a:solidFill>
+                <a:srgbClr val="222222"/>
+              </a:solidFill>
+            </a:endParaRPr>
+          </a:p>
+          <a:p>
+            <a:pPr>
+              <a:spcAft>
+                <a:spcPts val="1200"/>
+              </a:spcAft>
+            </a:pPr>
+            <a:r>
+              <a:rPr lang="es-ES" sz="2000" dirty="0">
+                <a:solidFill>
+                  <a:srgbClr val="222222"/>
+                </a:solidFill>
+              </a:rPr>
+              <a:t>•  Como esperaba, es la parte que más iteraciones ha requerido hasta obtener el resultado deseado</a:t>
+            </a:r>
+          </a:p>
+          <a:p>
+            <a:pPr>
+              <a:spcAft>
+                <a:spcPts val="1200"/>
+              </a:spcAft>
+            </a:pPr>
+            <a:endParaRPr sz="2000" dirty="0">
+              <a:solidFill>
+                <a:srgbClr val="222222"/>
+              </a:solidFill>
+            </a:endParaRPr>
           </a:p>
         </p:txBody>
       </p:sp>
@@ -6755,7 +6799,7 @@
         <p:spPr>
           <a:xfrm>
             <a:off x="1188719" y="2239709"/>
-            <a:ext cx="8643437" cy="2246769"/>
+            <a:ext cx="9765031" cy="2246769"/>
           </a:xfrm>
           <a:prstGeom prst="rect">
             <a:avLst/>
@@ -7293,6 +7337,14 @@
           <a:lstStyle/>
           <a:p>
             <a:pPr algn="ctr"/>
+            <a:r>
+              <a:rPr lang="es-ES">
+                <a:solidFill>
+                  <a:srgbClr val="222222"/>
+                </a:solidFill>
+              </a:rPr>
+              <a:t>El motor debe implementarse en el sistema de workflow de la entidad. Se ha facilitado el código fuente</a:t>
+            </a:r>
             <a:endParaRPr/>
           </a:p>
         </p:txBody>
@@ -7417,13 +7469,13 @@
           <p:nvPr>
             <p:extLst>
               <p:ext uri="{D42A27DB-BD31-4B8C-83A1-F6EECF244321}">
-                <p14:modId xmlns:p14="http://schemas.microsoft.com/office/powerpoint/2010/main" val="657135148"/>
+                <p14:modId xmlns:p14="http://schemas.microsoft.com/office/powerpoint/2010/main" val="277882097"/>
               </p:ext>
             </p:extLst>
           </p:nvPr>
         </p:nvGraphicFramePr>
         <p:xfrm>
-          <a:off x="548640" y="1417320"/>
+          <a:off x="960120" y="1463040"/>
           <a:ext cx="11064240" cy="3520440"/>
         </p:xfrm>
         <a:graphic>
@@ -7627,7 +7679,7 @@
                         </a:defRPr>
                       </a:pPr>
                       <a:r>
-                        <a:rPr sz="1800"/>
+                        <a:rPr sz="1800" dirty="0"/>
                         <a:t>BD</a:t>
                       </a:r>
                     </a:p>
@@ -7682,7 +7734,7 @@
                         </a:defRPr>
                       </a:pPr>
                       <a:r>
-                        <a:rPr sz="1800"/>
+                        <a:rPr sz="1800" dirty="0"/>
                         <a:t>Frontend</a:t>
                       </a:r>
                     </a:p>
@@ -9999,7 +10051,7 @@
         <p:spPr>
           <a:xfrm>
             <a:off x="548640" y="1417320"/>
-            <a:ext cx="7863840" cy="461665"/>
+            <a:ext cx="9857610" cy="461665"/>
           </a:xfrm>
           <a:prstGeom prst="rect">
             <a:avLst/>
@@ -10100,6 +10152,14 @@
               </a:rPr>
               <a:t>diferenciados</a:t>
             </a:r>
+            <a:r>
+              <a:rPr lang="es-ES" sz="2400" b="1" dirty="0">
+                <a:solidFill>
+                  <a:srgbClr val="222222"/>
+                </a:solidFill>
+              </a:rPr>
+              <a:t> en hipotecas</a:t>
+            </a:r>
             <a:endParaRPr sz="2400" b="1" dirty="0">
               <a:solidFill>
                 <a:srgbClr val="222222"/>
@@ -10117,7 +10177,7 @@
         <p:spPr>
           <a:xfrm>
             <a:off x="1190605" y="2148840"/>
-            <a:ext cx="9857610" cy="3785652"/>
+            <a:ext cx="9857610" cy="3477875"/>
           </a:xfrm>
           <a:prstGeom prst="rect">
             <a:avLst/>
@@ -10130,10 +10190,12 @@
           </a:bodyPr>
           <a:lstStyle/>
           <a:p>
-            <a:pPr>
+            <a:pPr marL="342900" indent="-342900">
               <a:spcAft>
                 <a:spcPts val="1200"/>
               </a:spcAft>
+              <a:buFont typeface="Arial" panose="020B0604020202020204" pitchFamily="34" charset="0"/>
+              <a:buChar char="•"/>
             </a:pPr>
             <a:r>
               <a:rPr sz="2000" dirty="0">
@@ -10141,7 +10203,7 @@
                   <a:srgbClr val="222222"/>
                 </a:solidFill>
               </a:rPr>
-              <a:t>•  Cada </a:t>
+              <a:t>Cada </a:t>
             </a:r>
             <a:r>
               <a:rPr sz="2000" dirty="0" err="1">
@@ -10189,7 +10251,15 @@
                   <a:srgbClr val="222222"/>
                 </a:solidFill>
               </a:rPr>
-              <a:t> derecho a </a:t>
+              <a:t> </a:t>
+            </a:r>
+            <a:r>
+              <a:rPr lang="es-ES" sz="2000" dirty="0">
+                <a:solidFill>
+                  <a:srgbClr val="222222"/>
+                </a:solidFill>
+              </a:rPr>
+              <a:t>asignada </a:t>
             </a:r>
             <a:r>
               <a:rPr sz="2000" dirty="0" err="1">
@@ -10224,20 +10294,12 @@
               <a:t> </a:t>
             </a:r>
             <a:r>
-              <a:rPr sz="2000" dirty="0" err="1">
-                <a:solidFill>
-                  <a:srgbClr val="222222"/>
-                </a:solidFill>
-              </a:rPr>
-              <a:t>distinta</a:t>
-            </a:r>
-            <a:r>
               <a:rPr lang="es-ES" sz="2000" dirty="0">
                 <a:solidFill>
                   <a:srgbClr val="222222"/>
                 </a:solidFill>
               </a:rPr>
-              <a:t> que además permite extender parámetros estándar </a:t>
+              <a:t>de precios en función de varios parámetros </a:t>
             </a:r>
             <a:r>
               <a:rPr sz="2000" dirty="0">
@@ -10330,18 +10392,28 @@
             </a:endParaRPr>
           </a:p>
           <a:p>
-            <a:pPr>
+            <a:pPr marL="342900" indent="-342900">
               <a:spcAft>
                 <a:spcPts val="1200"/>
               </a:spcAft>
+              <a:buFont typeface="Arial" panose="020B0604020202020204" pitchFamily="34" charset="0"/>
+              <a:buChar char="•"/>
             </a:pPr>
             <a:r>
-              <a:rPr sz="2000" dirty="0">
-                <a:solidFill>
-                  <a:srgbClr val="222222"/>
-                </a:solidFill>
-              </a:rPr>
-              <a:t>•  Las </a:t>
+              <a:rPr lang="es-ES" sz="2000" dirty="0">
+                <a:solidFill>
+                  <a:srgbClr val="222222"/>
+                </a:solidFill>
+              </a:rPr>
+              <a:t>El usuario planteaba una tabla parametrizada para realizar el cálculo de perfil-&gt;oferta. Inicialmente parecía una solución simple y suficiente, pero durante la definición de requisitos, el usuario cambiaba tanto la parametrización de l</a:t>
+            </a:r>
+            <a:r>
+              <a:rPr sz="2000" dirty="0">
+                <a:solidFill>
+                  <a:srgbClr val="222222"/>
+                </a:solidFill>
+              </a:rPr>
+              <a:t>as </a:t>
             </a:r>
             <a:r>
               <a:rPr sz="2000" dirty="0" err="1">
@@ -10357,107 +10429,16 @@
                   <a:srgbClr val="222222"/>
                 </a:solidFill>
               </a:rPr>
-              <a:t> </a:t>
-            </a:r>
-            <a:r>
-              <a:rPr sz="2000" dirty="0" err="1">
-                <a:solidFill>
-                  <a:srgbClr val="222222"/>
-                </a:solidFill>
-              </a:rPr>
-              <a:t>cambian</a:t>
-            </a:r>
-            <a:r>
-              <a:rPr sz="2000" dirty="0">
-                <a:solidFill>
-                  <a:srgbClr val="222222"/>
-                </a:solidFill>
-              </a:rPr>
-              <a:t> con el </a:t>
-            </a:r>
-            <a:r>
-              <a:rPr sz="2000" dirty="0" err="1">
-                <a:solidFill>
-                  <a:srgbClr val="222222"/>
-                </a:solidFill>
-              </a:rPr>
-              <a:t>tiempo</a:t>
-            </a:r>
-            <a:r>
-              <a:rPr sz="2000" dirty="0">
-                <a:solidFill>
-                  <a:srgbClr val="222222"/>
-                </a:solidFill>
-              </a:rPr>
-              <a:t> → hay </a:t>
-            </a:r>
-            <a:r>
-              <a:rPr sz="2000" dirty="0" err="1">
-                <a:solidFill>
-                  <a:srgbClr val="222222"/>
-                </a:solidFill>
-              </a:rPr>
-              <a:t>que</a:t>
-            </a:r>
-            <a:r>
-              <a:rPr sz="2000" dirty="0">
-                <a:solidFill>
-                  <a:srgbClr val="222222"/>
-                </a:solidFill>
-              </a:rPr>
-              <a:t> </a:t>
-            </a:r>
-            <a:r>
-              <a:rPr sz="2000" dirty="0" err="1">
-                <a:solidFill>
-                  <a:srgbClr val="222222"/>
-                </a:solidFill>
-              </a:rPr>
-              <a:t>historificar</a:t>
-            </a:r>
-            <a:r>
-              <a:rPr sz="2000" dirty="0">
-                <a:solidFill>
-                  <a:srgbClr val="222222"/>
-                </a:solidFill>
-              </a:rPr>
-              <a:t> y </a:t>
-            </a:r>
-            <a:r>
-              <a:rPr sz="2000" dirty="0" err="1">
-                <a:solidFill>
-                  <a:srgbClr val="222222"/>
-                </a:solidFill>
-              </a:rPr>
-              <a:t>poder</a:t>
-            </a:r>
-            <a:r>
-              <a:rPr sz="2000" dirty="0">
-                <a:solidFill>
-                  <a:srgbClr val="222222"/>
-                </a:solidFill>
-              </a:rPr>
-              <a:t> </a:t>
-            </a:r>
-            <a:r>
-              <a:rPr sz="2000" dirty="0" err="1">
-                <a:solidFill>
-                  <a:srgbClr val="222222"/>
-                </a:solidFill>
-              </a:rPr>
-              <a:t>simular</a:t>
-            </a:r>
-            <a:endParaRPr lang="es-ES" sz="2000" dirty="0">
-              <a:solidFill>
-                <a:srgbClr val="222222"/>
-              </a:solidFill>
-            </a:endParaRPr>
-          </a:p>
-          <a:p>
-            <a:pPr>
+              <a:t>, como las propias condiciones constantemente. </a:t>
+            </a:r>
+          </a:p>
+          <a:p>
+            <a:pPr marL="342900" indent="-342900">
               <a:spcAft>
                 <a:spcPts val="1200"/>
               </a:spcAft>
+              <a:buFont typeface="Arial" panose="020B0604020202020204" pitchFamily="34" charset="0"/>
+              <a:buChar char="•"/>
             </a:pPr>
             <a:endParaRPr lang="es-ES" sz="2000" dirty="0">
               <a:solidFill>
@@ -10466,10 +10447,12 @@
             </a:endParaRPr>
           </a:p>
           <a:p>
-            <a:pPr>
+            <a:pPr marL="342900" indent="-342900">
               <a:spcAft>
                 <a:spcPts val="1200"/>
               </a:spcAft>
+              <a:buFont typeface="Arial" panose="020B0604020202020204" pitchFamily="34" charset="0"/>
+              <a:buChar char="•"/>
             </a:pPr>
             <a:r>
               <a:rPr lang="es-ES" sz="2000" dirty="0">
@@ -10477,27 +10460,8 @@
                   <a:srgbClr val="222222"/>
                 </a:solidFill>
               </a:rPr>
-              <a:t>•  La solución completa debe estar implementada en menos de 2 meses (el motor de elegibilidad de ofertas es solo una pequeña parte del problema). </a:t>
-            </a:r>
-          </a:p>
-          <a:p>
-            <a:pPr>
-              <a:spcAft>
-                <a:spcPts val="1200"/>
-              </a:spcAft>
-            </a:pPr>
-            <a:endParaRPr lang="es-ES" sz="2000" dirty="0">
-              <a:solidFill>
-                <a:srgbClr val="222222"/>
-              </a:solidFill>
-            </a:endParaRPr>
-          </a:p>
-          <a:p>
-            <a:pPr>
-              <a:spcAft>
-                <a:spcPts val="1200"/>
-              </a:spcAft>
-            </a:pPr>
+              <a:t>Querían que la solución completa estuviera implementada en menos de 2 meses</a:t>
+            </a:r>
             <a:endParaRPr sz="2000" dirty="0">
               <a:solidFill>
                 <a:srgbClr val="222222"/>
@@ -10870,7 +10834,7 @@
         <p:spPr>
           <a:xfrm>
             <a:off x="1188720" y="2353985"/>
-            <a:ext cx="9746373" cy="4001095"/>
+            <a:ext cx="9746373" cy="4093428"/>
           </a:xfrm>
           <a:prstGeom prst="rect">
             <a:avLst/>
@@ -10883,10 +10847,12 @@
           </a:bodyPr>
           <a:lstStyle/>
           <a:p>
-            <a:pPr>
+            <a:pPr marL="342900" indent="-342900">
               <a:spcAft>
                 <a:spcPts val="1200"/>
               </a:spcAft>
+              <a:buFont typeface="Arial" panose="020B0604020202020204" pitchFamily="34" charset="0"/>
+              <a:buChar char="•"/>
             </a:pPr>
             <a:r>
               <a:rPr lang="es-ES" sz="2000" dirty="0">
@@ -10894,14 +10860,16 @@
                   <a:srgbClr val="222222"/>
                 </a:solidFill>
               </a:rPr>
-              <a:t>• La entidad requería condiciones parametrizadas para cada producto. En poco tiempo las condiciones han ido cambiando, el número de ofertas se ha incrementado y el conjunto de ofertas x condiciones x parámetros se hacía inmanejable. </a:t>
-            </a:r>
-          </a:p>
-          <a:p>
-            <a:pPr>
+              <a:t>Una tabla de decisión o un algoritmo con condiciones fijas implicaba rigidez a la hora de definir las reglas y modificación de código/despliegue en cada cambio.</a:t>
+            </a:r>
+          </a:p>
+          <a:p>
+            <a:pPr marL="342900" indent="-342900">
               <a:spcAft>
                 <a:spcPts val="1200"/>
               </a:spcAft>
+              <a:buFont typeface="Arial" panose="020B0604020202020204" pitchFamily="34" charset="0"/>
+              <a:buChar char="•"/>
             </a:pPr>
             <a:r>
               <a:rPr lang="es-ES" sz="2000" dirty="0">
@@ -10909,61 +10877,159 @@
                   <a:srgbClr val="222222"/>
                 </a:solidFill>
               </a:rPr>
-              <a:t>• Un algoritmo con condiciones fijas implicaba rigidez a la hora de definir las reglas y modificación de código/despliegue en cada cambio.</a:t>
-            </a:r>
-          </a:p>
-          <a:p>
-            <a:pPr>
+              <a:t>Pensé en un modelo de “motor de reglas” para resolver el problema. Se podrían definir por configuración un conjunto de condiciones que usen valores parametrizables. La solución permitiría el cálculo de ofertas:</a:t>
+            </a:r>
+          </a:p>
+          <a:p>
+            <a:pPr marL="800100" lvl="1" indent="-342900">
               <a:spcAft>
                 <a:spcPts val="1200"/>
               </a:spcAft>
+              <a:buFont typeface="Arial" panose="020B0604020202020204" pitchFamily="34" charset="0"/>
+              <a:buChar char="•"/>
             </a:pPr>
             <a:r>
-              <a:rPr lang="es-ES" sz="2000" dirty="0">
-                <a:solidFill>
-                  <a:srgbClr val="222222"/>
-                </a:solidFill>
-              </a:rPr>
-              <a:t>• Un motor de reglas permitiría definir por configuración un conjunto de condiciones que usen valores parametrizables. La solución permitiría el cálculo de ofertas:</a:t>
-            </a:r>
-          </a:p>
-          <a:p>
-            <a:pPr>
+              <a:rPr sz="2000" dirty="0">
+                <a:solidFill>
+                  <a:srgbClr val="222222"/>
+                </a:solidFill>
+              </a:rPr>
+              <a:t>Sin </a:t>
+            </a:r>
+            <a:r>
+              <a:rPr sz="2000" dirty="0" err="1">
+                <a:solidFill>
+                  <a:srgbClr val="222222"/>
+                </a:solidFill>
+              </a:rPr>
+              <a:t>recompilar</a:t>
+            </a:r>
+            <a:r>
+              <a:rPr sz="2000" dirty="0">
+                <a:solidFill>
+                  <a:srgbClr val="222222"/>
+                </a:solidFill>
+              </a:rPr>
+              <a:t> </a:t>
+            </a:r>
+            <a:r>
+              <a:rPr sz="2000" dirty="0" err="1">
+                <a:solidFill>
+                  <a:srgbClr val="222222"/>
+                </a:solidFill>
+              </a:rPr>
+              <a:t>ni</a:t>
+            </a:r>
+            <a:r>
+              <a:rPr sz="2000" dirty="0">
+                <a:solidFill>
+                  <a:srgbClr val="222222"/>
+                </a:solidFill>
+              </a:rPr>
+              <a:t> </a:t>
+            </a:r>
+            <a:r>
+              <a:rPr sz="2000" dirty="0" err="1">
+                <a:solidFill>
+                  <a:srgbClr val="222222"/>
+                </a:solidFill>
+              </a:rPr>
+              <a:t>tocar</a:t>
+            </a:r>
+            <a:r>
+              <a:rPr sz="2000" dirty="0">
+                <a:solidFill>
+                  <a:srgbClr val="222222"/>
+                </a:solidFill>
+              </a:rPr>
+              <a:t> </a:t>
+            </a:r>
+            <a:r>
+              <a:rPr sz="2000" dirty="0" err="1">
+                <a:solidFill>
+                  <a:srgbClr val="222222"/>
+                </a:solidFill>
+              </a:rPr>
+              <a:t>código</a:t>
+            </a:r>
+            <a:r>
+              <a:rPr sz="2000" dirty="0">
+                <a:solidFill>
+                  <a:srgbClr val="222222"/>
+                </a:solidFill>
+              </a:rPr>
+              <a:t>: </a:t>
+            </a:r>
+            <a:r>
+              <a:rPr sz="2000" dirty="0" err="1">
+                <a:solidFill>
+                  <a:srgbClr val="222222"/>
+                </a:solidFill>
+              </a:rPr>
+              <a:t>todo</a:t>
+            </a:r>
+            <a:r>
+              <a:rPr sz="2000" dirty="0">
+                <a:solidFill>
+                  <a:srgbClr val="222222"/>
+                </a:solidFill>
+              </a:rPr>
+              <a:t> es </a:t>
+            </a:r>
+            <a:r>
+              <a:rPr sz="2000" dirty="0" err="1">
+                <a:solidFill>
+                  <a:srgbClr val="222222"/>
+                </a:solidFill>
+              </a:rPr>
+              <a:t>configuración</a:t>
+            </a:r>
+            <a:endParaRPr lang="es-ES" sz="2000" dirty="0">
+              <a:solidFill>
+                <a:srgbClr val="222222"/>
+              </a:solidFill>
+            </a:endParaRPr>
+          </a:p>
+          <a:p>
+            <a:pPr marL="800100" lvl="1" indent="-342900">
               <a:spcAft>
                 <a:spcPts val="1200"/>
               </a:spcAft>
+              <a:buFont typeface="Arial" panose="020B0604020202020204" pitchFamily="34" charset="0"/>
+              <a:buChar char="•"/>
             </a:pPr>
             <a:r>
-              <a:rPr lang="es-ES" sz="2400" dirty="0">
-                <a:solidFill>
-                  <a:srgbClr val="222222"/>
-                </a:solidFill>
-              </a:rPr>
-              <a:t>	</a:t>
-            </a:r>
-            <a:r>
-              <a:rPr sz="2400" dirty="0">
-                <a:solidFill>
-                  <a:srgbClr val="222222"/>
-                </a:solidFill>
-              </a:rPr>
-              <a:t>•  </a:t>
-            </a:r>
-            <a:r>
-              <a:rPr sz="2000" dirty="0">
-                <a:solidFill>
-                  <a:srgbClr val="222222"/>
-                </a:solidFill>
-              </a:rPr>
-              <a:t>Sin </a:t>
-            </a:r>
-            <a:r>
-              <a:rPr sz="2000" dirty="0" err="1">
-                <a:solidFill>
-                  <a:srgbClr val="222222"/>
-                </a:solidFill>
-              </a:rPr>
-              <a:t>recompilar</a:t>
+              <a:rPr lang="es-ES" sz="2000" dirty="0">
+                <a:solidFill>
+                  <a:srgbClr val="222222"/>
+                </a:solidFill>
+              </a:rPr>
+              <a:t>Flexibilidad para establecer condiciones complejas y añadir parámetros y variables de forma sencilla</a:t>
+            </a:r>
+          </a:p>
+          <a:p>
+            <a:pPr marL="800100" lvl="1" indent="-342900">
+              <a:spcAft>
+                <a:spcPts val="1200"/>
+              </a:spcAft>
+              <a:buFont typeface="Arial" panose="020B0604020202020204" pitchFamily="34" charset="0"/>
+              <a:buChar char="•"/>
+            </a:pPr>
+            <a:r>
+              <a:rPr lang="es-ES" sz="2000" dirty="0">
+                <a:solidFill>
+                  <a:srgbClr val="222222"/>
+                </a:solidFill>
+              </a:rPr>
+              <a:t>Requiere de una configuración de r</a:t>
+            </a:r>
+            <a:r>
+              <a:rPr sz="2000" dirty="0" err="1">
+                <a:solidFill>
+                  <a:srgbClr val="222222"/>
+                </a:solidFill>
+              </a:rPr>
+              <a:t>eglas</a:t>
             </a:r>
             <a:r>
               <a:rPr sz="2000" dirty="0">
@@ -10974,12 +11040,20 @@
               <a:t> </a:t>
             </a:r>
             <a:r>
-              <a:rPr sz="2000" dirty="0" err="1">
-                <a:solidFill>
-                  <a:srgbClr val="222222"/>
-                </a:solidFill>
-              </a:rPr>
-              <a:t>ni</a:t>
+              <a:rPr lang="es-ES" sz="2000" dirty="0">
+                <a:solidFill>
+                  <a:srgbClr val="222222"/>
+                </a:solidFill>
+              </a:rPr>
+              <a:t>por </a:t>
+            </a:r>
+            <a:r>
+              <a:rPr sz="2000" dirty="0" err="1">
+                <a:solidFill>
+                  <a:srgbClr val="222222"/>
+                </a:solidFill>
+              </a:rPr>
+              <a:t>perfil</a:t>
             </a:r>
             <a:r>
               <a:rPr sz="2000" dirty="0">
@@ -10995,7 +11069,31 @@
                   <a:srgbClr val="222222"/>
                 </a:solidFill>
               </a:rPr>
-              <a:t>tocar</a:t>
+              <a:t>técnico</a:t>
+            </a:r>
+            <a:r>
+              <a:rPr lang="es-ES" sz="2000" dirty="0">
+                <a:solidFill>
+                  <a:srgbClr val="222222"/>
+                </a:solidFill>
+              </a:rPr>
+              <a:t>, pero la definición de </a:t>
+            </a:r>
+            <a:r>
+              <a:rPr sz="2000" dirty="0">
+                <a:solidFill>
+                  <a:srgbClr val="222222"/>
+                </a:solidFill>
+              </a:rPr>
+              <a:t>· </a:t>
+            </a:r>
+            <a:r>
+              <a:rPr sz="2000" dirty="0" err="1">
+                <a:solidFill>
+                  <a:srgbClr val="222222"/>
+                </a:solidFill>
+              </a:rPr>
+              <a:t>parámetros</a:t>
             </a:r>
             <a:r>
               <a:rPr sz="2000" dirty="0">
@@ -11006,325 +11104,90 @@
               <a:t> </a:t>
             </a:r>
             <a:r>
-              <a:rPr sz="2000" dirty="0" err="1">
-                <a:solidFill>
-                  <a:srgbClr val="222222"/>
-                </a:solidFill>
-              </a:rPr>
-              <a:t>código</a:t>
-            </a:r>
-            <a:r>
-              <a:rPr sz="2000" dirty="0">
-                <a:solidFill>
-                  <a:srgbClr val="222222"/>
-                </a:solidFill>
-              </a:rPr>
-              <a:t>: </a:t>
-            </a:r>
-            <a:r>
-              <a:rPr sz="2000" dirty="0" err="1">
-                <a:solidFill>
-                  <a:srgbClr val="222222"/>
-                </a:solidFill>
-              </a:rPr>
-              <a:t>todo</a:t>
-            </a:r>
-            <a:r>
-              <a:rPr sz="2000" dirty="0">
-                <a:solidFill>
-                  <a:srgbClr val="222222"/>
-                </a:solidFill>
-              </a:rPr>
-              <a:t> es </a:t>
-            </a:r>
-            <a:r>
-              <a:rPr sz="2000" dirty="0" err="1">
-                <a:solidFill>
-                  <a:srgbClr val="222222"/>
-                </a:solidFill>
-              </a:rPr>
-              <a:t>configuración</a:t>
+              <a:rPr lang="es-ES" sz="2000" dirty="0">
+                <a:solidFill>
+                  <a:srgbClr val="222222"/>
+                </a:solidFill>
+              </a:rPr>
+              <a:t>(</a:t>
+            </a:r>
+            <a:r>
+              <a:rPr lang="es-ES" sz="2000" dirty="0" err="1">
+                <a:solidFill>
+                  <a:srgbClr val="222222"/>
+                </a:solidFill>
+              </a:rPr>
+              <a:t>ej</a:t>
+            </a:r>
+            <a:r>
+              <a:rPr lang="es-ES" sz="2000" dirty="0">
+                <a:solidFill>
+                  <a:srgbClr val="222222"/>
+                </a:solidFill>
+              </a:rPr>
+              <a:t>: edad máxima, importes </a:t>
+            </a:r>
+            <a:r>
+              <a:rPr lang="es-ES" sz="2000" dirty="0" err="1">
+                <a:solidFill>
+                  <a:srgbClr val="222222"/>
+                </a:solidFill>
+              </a:rPr>
+              <a:t>mín</a:t>
+            </a:r>
+            <a:r>
+              <a:rPr lang="es-ES" sz="2000" dirty="0">
+                <a:solidFill>
+                  <a:srgbClr val="222222"/>
+                </a:solidFill>
+              </a:rPr>
+              <a:t>/</a:t>
+            </a:r>
+            <a:r>
+              <a:rPr lang="es-ES" sz="2000" dirty="0" err="1">
+                <a:solidFill>
+                  <a:srgbClr val="222222"/>
+                </a:solidFill>
+              </a:rPr>
+              <a:t>max</a:t>
+            </a:r>
+            <a:r>
+              <a:rPr lang="es-ES" sz="2000" dirty="0">
+                <a:solidFill>
+                  <a:srgbClr val="222222"/>
+                </a:solidFill>
+              </a:rPr>
+              <a:t>, etc.) podría hacerlo un </a:t>
+            </a:r>
+            <a:r>
+              <a:rPr sz="2000" dirty="0" err="1">
+                <a:solidFill>
+                  <a:srgbClr val="222222"/>
+                </a:solidFill>
+              </a:rPr>
+              <a:t>perfil</a:t>
+            </a:r>
+            <a:r>
+              <a:rPr sz="2000" dirty="0">
+                <a:solidFill>
+                  <a:srgbClr val="222222"/>
+                </a:solidFill>
+              </a:rPr>
+              <a:t> de </a:t>
+            </a:r>
+            <a:r>
+              <a:rPr sz="2000" dirty="0" err="1">
+                <a:solidFill>
+                  <a:srgbClr val="222222"/>
+                </a:solidFill>
+              </a:rPr>
+              <a:t>negocio</a:t>
             </a:r>
             <a:endParaRPr sz="2000" dirty="0">
               <a:solidFill>
                 <a:srgbClr val="222222"/>
               </a:solidFill>
             </a:endParaRPr>
-          </a:p>
-          <a:p>
-            <a:pPr>
-              <a:spcAft>
-                <a:spcPts val="1200"/>
-              </a:spcAft>
-            </a:pPr>
-            <a:r>
-              <a:rPr lang="es-ES" sz="2000" dirty="0">
-                <a:solidFill>
-                  <a:srgbClr val="222222"/>
-                </a:solidFill>
-              </a:rPr>
-              <a:t>	</a:t>
-            </a:r>
-            <a:r>
-              <a:rPr sz="2000" dirty="0">
-                <a:solidFill>
-                  <a:srgbClr val="222222"/>
-                </a:solidFill>
-              </a:rPr>
-              <a:t>•  Reglas para </a:t>
-            </a:r>
-            <a:r>
-              <a:rPr sz="2000" dirty="0" err="1">
-                <a:solidFill>
-                  <a:srgbClr val="222222"/>
-                </a:solidFill>
-              </a:rPr>
-              <a:t>perfil</a:t>
-            </a:r>
-            <a:r>
-              <a:rPr sz="2000" dirty="0">
-                <a:solidFill>
-                  <a:srgbClr val="222222"/>
-                </a:solidFill>
-              </a:rPr>
-              <a:t> </a:t>
-            </a:r>
-            <a:r>
-              <a:rPr sz="2000" dirty="0" err="1">
-                <a:solidFill>
-                  <a:srgbClr val="222222"/>
-                </a:solidFill>
-              </a:rPr>
-              <a:t>técnico</a:t>
-            </a:r>
-            <a:r>
-              <a:rPr sz="2000" dirty="0">
-                <a:solidFill>
-                  <a:srgbClr val="222222"/>
-                </a:solidFill>
-              </a:rPr>
-              <a:t> · </a:t>
-            </a:r>
-            <a:r>
-              <a:rPr sz="2000" dirty="0" err="1">
-                <a:solidFill>
-                  <a:srgbClr val="222222"/>
-                </a:solidFill>
-              </a:rPr>
-              <a:t>parámetros</a:t>
-            </a:r>
-            <a:r>
-              <a:rPr sz="2000" dirty="0">
-                <a:solidFill>
-                  <a:srgbClr val="222222"/>
-                </a:solidFill>
-              </a:rPr>
-              <a:t> para </a:t>
-            </a:r>
-            <a:r>
-              <a:rPr sz="2000" dirty="0" err="1">
-                <a:solidFill>
-                  <a:srgbClr val="222222"/>
-                </a:solidFill>
-              </a:rPr>
-              <a:t>perfil</a:t>
-            </a:r>
-            <a:r>
-              <a:rPr sz="2000" dirty="0">
-                <a:solidFill>
-                  <a:srgbClr val="222222"/>
-                </a:solidFill>
-              </a:rPr>
-              <a:t> de </a:t>
-            </a:r>
-            <a:r>
-              <a:rPr sz="2000" dirty="0" err="1">
-                <a:solidFill>
-                  <a:srgbClr val="222222"/>
-                </a:solidFill>
-              </a:rPr>
-              <a:t>negocio</a:t>
-            </a:r>
-            <a:endParaRPr sz="2000" dirty="0">
-              <a:solidFill>
-                <a:srgbClr val="222222"/>
-              </a:solidFill>
-            </a:endParaRPr>
-          </a:p>
-          <a:p>
-            <a:pPr>
-              <a:spcAft>
-                <a:spcPts val="1200"/>
-              </a:spcAft>
-            </a:pPr>
-            <a:r>
-              <a:rPr lang="es-ES" sz="2000" dirty="0">
-                <a:solidFill>
-                  <a:srgbClr val="222222"/>
-                </a:solidFill>
-              </a:rPr>
-              <a:t>	</a:t>
-            </a:r>
-            <a:r>
-              <a:rPr sz="2000" dirty="0">
-                <a:solidFill>
-                  <a:srgbClr val="222222"/>
-                </a:solidFill>
-              </a:rPr>
-              <a:t>•  </a:t>
-            </a:r>
-            <a:r>
-              <a:rPr sz="2000" dirty="0" err="1">
-                <a:solidFill>
-                  <a:srgbClr val="222222"/>
-                </a:solidFill>
-              </a:rPr>
-              <a:t>Versionado</a:t>
-            </a:r>
-            <a:r>
-              <a:rPr sz="2000" dirty="0">
-                <a:solidFill>
-                  <a:srgbClr val="222222"/>
-                </a:solidFill>
-              </a:rPr>
-              <a:t> </a:t>
-            </a:r>
-            <a:r>
-              <a:rPr sz="2000" dirty="0" err="1">
-                <a:solidFill>
-                  <a:srgbClr val="222222"/>
-                </a:solidFill>
-              </a:rPr>
-              <a:t>por</a:t>
-            </a:r>
-            <a:r>
-              <a:rPr sz="2000" dirty="0">
-                <a:solidFill>
-                  <a:srgbClr val="222222"/>
-                </a:solidFill>
-              </a:rPr>
-              <a:t> </a:t>
-            </a:r>
-            <a:r>
-              <a:rPr sz="2000" dirty="0" err="1">
-                <a:solidFill>
-                  <a:srgbClr val="222222"/>
-                </a:solidFill>
-              </a:rPr>
-              <a:t>vigencias</a:t>
-            </a:r>
-            <a:r>
-              <a:rPr sz="2000" dirty="0">
-                <a:solidFill>
-                  <a:srgbClr val="222222"/>
-                </a:solidFill>
-              </a:rPr>
-              <a:t>: "</a:t>
-            </a:r>
-            <a:r>
-              <a:rPr sz="2000" dirty="0" err="1">
-                <a:solidFill>
-                  <a:srgbClr val="222222"/>
-                </a:solidFill>
-              </a:rPr>
-              <a:t>qué</a:t>
-            </a:r>
-            <a:r>
-              <a:rPr sz="2000" dirty="0">
-                <a:solidFill>
-                  <a:srgbClr val="222222"/>
-                </a:solidFill>
-              </a:rPr>
-              <a:t> </a:t>
-            </a:r>
-            <a:r>
-              <a:rPr sz="2000" dirty="0" err="1">
-                <a:solidFill>
-                  <a:srgbClr val="222222"/>
-                </a:solidFill>
-              </a:rPr>
-              <a:t>reglas</a:t>
-            </a:r>
-            <a:r>
-              <a:rPr sz="2000" dirty="0">
-                <a:solidFill>
-                  <a:srgbClr val="222222"/>
-                </a:solidFill>
-              </a:rPr>
-              <a:t> </a:t>
-            </a:r>
-            <a:r>
-              <a:rPr lang="es-ES" sz="2000" dirty="0">
-                <a:solidFill>
-                  <a:srgbClr val="222222"/>
-                </a:solidFill>
-              </a:rPr>
-              <a:t>y qué parámetros </a:t>
-            </a:r>
-            <a:r>
-              <a:rPr sz="2000" dirty="0" err="1">
-                <a:solidFill>
-                  <a:srgbClr val="222222"/>
-                </a:solidFill>
-              </a:rPr>
-              <a:t>aplicaban</a:t>
-            </a:r>
-            <a:r>
-              <a:rPr sz="2000" dirty="0">
-                <a:solidFill>
-                  <a:srgbClr val="222222"/>
-                </a:solidFill>
-              </a:rPr>
-              <a:t> </a:t>
-            </a:r>
-            <a:r>
-              <a:rPr sz="2000" dirty="0" err="1">
-                <a:solidFill>
-                  <a:srgbClr val="222222"/>
-                </a:solidFill>
-              </a:rPr>
-              <a:t>en</a:t>
-            </a:r>
-            <a:r>
-              <a:rPr sz="2000" dirty="0">
-                <a:solidFill>
-                  <a:srgbClr val="222222"/>
-                </a:solidFill>
-              </a:rPr>
-              <a:t> </a:t>
-            </a:r>
-            <a:r>
-              <a:rPr sz="2000" dirty="0" err="1">
-                <a:solidFill>
-                  <a:srgbClr val="222222"/>
-                </a:solidFill>
-              </a:rPr>
-              <a:t>tal</a:t>
-            </a:r>
-            <a:r>
-              <a:rPr sz="2000" dirty="0">
-                <a:solidFill>
-                  <a:srgbClr val="222222"/>
-                </a:solidFill>
-              </a:rPr>
-              <a:t> </a:t>
-            </a:r>
-            <a:r>
-              <a:rPr sz="2000" dirty="0" err="1">
-                <a:solidFill>
-                  <a:srgbClr val="222222"/>
-                </a:solidFill>
-              </a:rPr>
-              <a:t>fecha</a:t>
-            </a:r>
-            <a:r>
-              <a:rPr sz="2000" dirty="0">
-                <a:solidFill>
-                  <a:srgbClr val="222222"/>
-                </a:solidFill>
-              </a:rPr>
-              <a:t>"</a:t>
-            </a:r>
           </a:p>
         </p:txBody>
       </p:sp>
@@ -11715,7 +11578,7 @@
           <p:nvPr>
             <p:extLst>
               <p:ext uri="{D42A27DB-BD31-4B8C-83A1-F6EECF244321}">
-                <p14:modId xmlns:p14="http://schemas.microsoft.com/office/powerpoint/2010/main" val="262250775"/>
+                <p14:modId xmlns:p14="http://schemas.microsoft.com/office/powerpoint/2010/main" val="2922727162"/>
               </p:ext>
             </p:extLst>
           </p:nvPr>
@@ -11890,8 +11753,14 @@
                         </a:defRPr>
                       </a:pPr>
                       <a:r>
-                        <a:t>Datos mínimos</a:t>
+                        <a:rPr dirty="0"/>
+                        <a:t>Datos </a:t>
                       </a:r>
+                      <a:r>
+                        <a:rPr dirty="0" err="1"/>
+                        <a:t>mínimos</a:t>
+                      </a:r>
+                      <a:endParaRPr dirty="0"/>
                     </a:p>
                   </a:txBody>
                   <a:tcPr>
@@ -11944,8 +11813,30 @@
                         </a:defRPr>
                       </a:pPr>
                       <a:r>
-                        <a:t>Pre-elegibilidad + límites del simulador</a:t>
+                        <a:rPr dirty="0"/>
+                        <a:t>Pre-</a:t>
                       </a:r>
+                      <a:r>
+                        <a:rPr dirty="0" err="1"/>
+                        <a:t>elegibilidad</a:t>
+                      </a:r>
+                      <a:r>
+                        <a:rPr dirty="0"/>
+                        <a:t> + </a:t>
+                      </a:r>
+                      <a:r>
+                        <a:rPr dirty="0" err="1"/>
+                        <a:t>límites</a:t>
+                      </a:r>
+                      <a:r>
+                        <a:rPr dirty="0"/>
+                        <a:t> del </a:t>
+                      </a:r>
+                      <a:r>
+                        <a:rPr dirty="0" err="1"/>
+                        <a:t>simulador</a:t>
+                      </a:r>
+                      <a:endParaRPr dirty="0"/>
                     </a:p>
                   </a:txBody>
                   <a:tcPr>
@@ -11967,8 +11858,10 @@
                         </a:defRPr>
                       </a:pPr>
                       <a:r>
-                        <a:t>Simulación inicial</a:t>
+                        <a:rPr lang="es-ES" dirty="0"/>
+                        <a:t>Datos económicos y añadir titulares</a:t>
                       </a:r>
+                      <a:endParaRPr dirty="0"/>
                     </a:p>
                   </a:txBody>
                   <a:tcPr>
@@ -12087,7 +11980,7 @@
         <p:spPr>
           <a:xfrm>
             <a:off x="477520" y="2011680"/>
-            <a:ext cx="11064240" cy="1477328"/>
+            <a:ext cx="11320780" cy="1384995"/>
           </a:xfrm>
           <a:prstGeom prst="rect">
             <a:avLst/>
@@ -12100,21 +11993,23 @@
           </a:bodyPr>
           <a:lstStyle/>
           <a:p>
-            <a:pPr>
+            <a:pPr marL="342900" indent="-342900">
               <a:spcAft>
                 <a:spcPts val="1800"/>
               </a:spcAft>
+              <a:buFont typeface="Arial" panose="020B0604020202020204" pitchFamily="34" charset="0"/>
+              <a:buChar char="•"/>
             </a:pPr>
             <a:r>
-              <a:rPr sz="2000" dirty="0">
-                <a:solidFill>
-                  <a:srgbClr val="222222"/>
-                </a:solidFill>
-              </a:rPr>
-              <a:t>•  La </a:t>
-            </a:r>
-            <a:r>
-              <a:rPr lang="es-ES" sz="2000" dirty="0">
+              <a:rPr dirty="0">
+                <a:solidFill>
+                  <a:srgbClr val="222222"/>
+                </a:solidFill>
+              </a:rPr>
+              <a:t>La </a:t>
+            </a:r>
+            <a:r>
+              <a:rPr lang="es-ES" dirty="0">
                 <a:solidFill>
                   <a:srgbClr val="222222"/>
                 </a:solidFill>
@@ -12123,33 +12018,37 @@
             </a:r>
           </a:p>
           <a:p>
-            <a:pPr>
+            <a:pPr marL="342900" indent="-342900">
               <a:spcAft>
                 <a:spcPts val="1800"/>
               </a:spcAft>
+              <a:buFont typeface="Arial" panose="020B0604020202020204" pitchFamily="34" charset="0"/>
+              <a:buChar char="•"/>
             </a:pPr>
             <a:r>
-              <a:rPr lang="es-ES" sz="2000" dirty="0">
-                <a:solidFill>
-                  <a:srgbClr val="222222"/>
-                </a:solidFill>
-              </a:rPr>
-              <a:t>•  En cada paso hay conjuntos de información diferente que hay que evaluar. </a:t>
-            </a:r>
-          </a:p>
-          <a:p>
-            <a:pPr>
+              <a:rPr lang="es-ES" dirty="0">
+                <a:solidFill>
+                  <a:srgbClr val="222222"/>
+                </a:solidFill>
+              </a:rPr>
+              <a:t>En cada paso hay conjuntos de información diferente que hay que evaluar. </a:t>
+            </a:r>
+          </a:p>
+          <a:p>
+            <a:pPr marL="342900" indent="-342900">
               <a:spcAft>
                 <a:spcPts val="1800"/>
               </a:spcAft>
+              <a:buFont typeface="Arial" panose="020B0604020202020204" pitchFamily="34" charset="0"/>
+              <a:buChar char="•"/>
             </a:pPr>
             <a:r>
-              <a:rPr lang="es-ES" sz="2000" dirty="0">
-                <a:solidFill>
-                  <a:srgbClr val="222222"/>
-                </a:solidFill>
-              </a:rPr>
-              <a:t>• Se define un modelo de ejecución por fase a medida que se obtienen los datos necesarios</a:t>
+              <a:rPr lang="es-ES" dirty="0">
+                <a:solidFill>
+                  <a:srgbClr val="222222"/>
+                </a:solidFill>
+              </a:rPr>
+              <a:t>Se define un modelo de ejecución por fase a medida que se obtienen los datos necesarios</a:t>
             </a:r>
           </a:p>
         </p:txBody>
@@ -12169,7 +12068,7 @@
         <p:spPr>
           <a:xfrm>
             <a:off x="563727" y="5794950"/>
-            <a:ext cx="11064240" cy="400110"/>
+            <a:ext cx="11064240" cy="369332"/>
           </a:xfrm>
           <a:prstGeom prst="rect">
             <a:avLst/>
@@ -12188,15 +12087,15 @@
               </a:spcAft>
             </a:pPr>
             <a:r>
-              <a:rPr sz="2000" dirty="0">
-                <a:solidFill>
-                  <a:srgbClr val="222222"/>
-                </a:solidFill>
-              </a:rPr>
-              <a:t>•  La </a:t>
-            </a:r>
-            <a:r>
-              <a:rPr sz="2000" dirty="0" err="1">
+              <a:rPr dirty="0">
+                <a:solidFill>
+                  <a:srgbClr val="222222"/>
+                </a:solidFill>
+              </a:rPr>
+              <a:t>La </a:t>
+            </a:r>
+            <a:r>
+              <a:rPr dirty="0" err="1">
                 <a:solidFill>
                   <a:srgbClr val="222222"/>
                 </a:solidFill>
@@ -12204,7 +12103,7 @@
               <a:t>oferta</a:t>
             </a:r>
             <a:r>
-              <a:rPr sz="2000" dirty="0">
+              <a:rPr dirty="0">
                 <a:solidFill>
                   <a:srgbClr val="222222"/>
                 </a:solidFill>
@@ -12212,7 +12111,7 @@
               <a:t> </a:t>
             </a:r>
             <a:r>
-              <a:rPr sz="2000" dirty="0" err="1">
+              <a:rPr dirty="0" err="1">
                 <a:solidFill>
                   <a:srgbClr val="222222"/>
                 </a:solidFill>
@@ -12220,7 +12119,7 @@
               <a:t>ganadora</a:t>
             </a:r>
             <a:r>
-              <a:rPr sz="2000" dirty="0">
+              <a:rPr dirty="0">
                 <a:solidFill>
                   <a:srgbClr val="222222"/>
                 </a:solidFill>
@@ -12228,7 +12127,7 @@
               <a:t> = la </a:t>
             </a:r>
             <a:r>
-              <a:rPr sz="2000" dirty="0" err="1">
+              <a:rPr dirty="0" err="1">
                 <a:solidFill>
                   <a:srgbClr val="222222"/>
                 </a:solidFill>
@@ -12236,22 +12135,38 @@
               <a:t>elegible</a:t>
             </a:r>
             <a:r>
-              <a:rPr sz="2000" dirty="0">
-                <a:solidFill>
-                  <a:srgbClr val="222222"/>
-                </a:solidFill>
-              </a:rPr>
-              <a:t> con mayor </a:t>
-            </a:r>
-            <a:r>
-              <a:rPr lang="es-ES" sz="2000" dirty="0">
+              <a:rPr dirty="0">
+                <a:solidFill>
+                  <a:srgbClr val="222222"/>
+                </a:solidFill>
+              </a:rPr>
+              <a:t> con may</a:t>
+            </a:r>
+            <a:r>
+              <a:rPr lang="es-ES" dirty="0" err="1">
+                <a:solidFill>
+                  <a:srgbClr val="222222"/>
+                </a:solidFill>
+              </a:rPr>
+              <a:t>or</a:t>
+            </a:r>
+            <a:r>
+              <a:rPr dirty="0">
+                <a:solidFill>
+                  <a:srgbClr val="222222"/>
+                </a:solidFill>
+              </a:rPr>
+              <a:t> </a:t>
+            </a:r>
+            <a:r>
+              <a:rPr lang="es-ES" dirty="0">
                 <a:solidFill>
                   <a:srgbClr val="222222"/>
                 </a:solidFill>
               </a:rPr>
               <a:t>rango</a:t>
             </a:r>
-            <a:endParaRPr sz="2000" dirty="0">
+            <a:endParaRPr dirty="0">
               <a:solidFill>
                 <a:srgbClr val="222222"/>
               </a:solidFill>
@@ -14102,7 +14017,7 @@
         <p:spPr>
           <a:xfrm>
             <a:off x="1188720" y="2107603"/>
-            <a:ext cx="9576690" cy="2554545"/>
+            <a:ext cx="9576690" cy="4478149"/>
           </a:xfrm>
           <a:prstGeom prst="rect">
             <a:avLst/>
@@ -14374,23 +14289,31 @@
                   <a:srgbClr val="222222"/>
                 </a:solidFill>
               </a:rPr>
-              <a:t> (`</a:t>
-            </a:r>
-            <a:r>
-              <a:rPr sz="2000" dirty="0" err="1">
-                <a:solidFill>
-                  <a:srgbClr val="222222"/>
-                </a:solidFill>
-              </a:rPr>
-              <a:t>rules.json</a:t>
-            </a:r>
-            <a:r>
-              <a:rPr sz="2000" dirty="0">
-                <a:solidFill>
-                  <a:srgbClr val="222222"/>
-                </a:solidFill>
-              </a:rPr>
-              <a:t>`) </a:t>
+              <a:t> (</a:t>
+            </a:r>
+            <a:r>
+              <a:rPr lang="es-ES" sz="2000" dirty="0" err="1">
+                <a:solidFill>
+                  <a:srgbClr val="222222"/>
+                </a:solidFill>
+              </a:rPr>
+              <a:t>seed</a:t>
+            </a:r>
+            <a:r>
+              <a:rPr lang="es-ES" sz="2000" dirty="0">
+                <a:solidFill>
+                  <a:srgbClr val="222222"/>
+                </a:solidFill>
+              </a:rPr>
+              <a:t> de reglas, ofertas, parámetros</a:t>
+            </a:r>
+            <a:r>
+              <a:rPr sz="2000" dirty="0">
+                <a:solidFill>
+                  <a:srgbClr val="222222"/>
+                </a:solidFill>
+              </a:rPr>
+              <a:t>) </a:t>
             </a:r>
             <a:r>
               <a:rPr sz="2000" dirty="0" err="1">
@@ -14529,6 +14452,37 @@
               </a:spcAft>
             </a:pPr>
             <a:r>
+              <a:rPr lang="es-ES" sz="2000" dirty="0">
+                <a:solidFill>
+                  <a:srgbClr val="222222"/>
+                </a:solidFill>
+              </a:rPr>
+              <a:t>•  Añadir utilidades para tomar </a:t>
+            </a:r>
+            <a:r>
+              <a:rPr lang="es-ES" sz="2000" dirty="0" err="1">
+                <a:solidFill>
+                  <a:srgbClr val="222222"/>
+                </a:solidFill>
+              </a:rPr>
+              <a:t>snapshots</a:t>
+            </a:r>
+            <a:r>
+              <a:rPr lang="es-ES" sz="2000" dirty="0">
+                <a:solidFill>
+                  <a:srgbClr val="222222"/>
+                </a:solidFill>
+              </a:rPr>
+              <a:t> de configuración y publicarlos entre entornos</a:t>
+            </a:r>
+          </a:p>
+          <a:p>
+            <a:pPr>
+              <a:spcAft>
+                <a:spcPts val="1800"/>
+              </a:spcAft>
+            </a:pPr>
+            <a:r>
               <a:rPr sz="2000" dirty="0">
                 <a:solidFill>
                   <a:srgbClr val="222222"/>
@@ -14592,6 +14546,30 @@
               </a:rPr>
               <a:t>evidencias</a:t>
             </a:r>
+            <a:endParaRPr lang="es-ES" sz="2000" dirty="0">
+              <a:solidFill>
+                <a:srgbClr val="222222"/>
+              </a:solidFill>
+            </a:endParaRPr>
+          </a:p>
+          <a:p>
+            <a:pPr>
+              <a:spcAft>
+                <a:spcPts val="1800"/>
+              </a:spcAft>
+            </a:pPr>
+            <a:endParaRPr lang="es-ES" sz="2000" dirty="0">
+              <a:solidFill>
+                <a:srgbClr val="222222"/>
+              </a:solidFill>
+            </a:endParaRPr>
+          </a:p>
+          <a:p>
+            <a:pPr>
+              <a:spcAft>
+                <a:spcPts val="1800"/>
+              </a:spcAft>
+            </a:pPr>
             <a:endParaRPr sz="2000" dirty="0">
               <a:solidFill>
                 <a:srgbClr val="222222"/>
@@ -14823,7 +14801,7 @@
         <p:spPr>
           <a:xfrm>
             <a:off x="895083" y="2305615"/>
-            <a:ext cx="10401527" cy="2554545"/>
+            <a:ext cx="10401527" cy="4170372"/>
           </a:xfrm>
           <a:prstGeom prst="rect">
             <a:avLst/>
@@ -15208,6 +15186,50 @@
               </a:rPr>
               <a:t> y auditable</a:t>
             </a:r>
+            <a:endParaRPr lang="es-ES" sz="2000" dirty="0">
+              <a:solidFill>
+                <a:srgbClr val="222222"/>
+              </a:solidFill>
+            </a:endParaRPr>
+          </a:p>
+          <a:p>
+            <a:pPr>
+              <a:spcAft>
+                <a:spcPts val="1800"/>
+              </a:spcAft>
+            </a:pPr>
+            <a:r>
+              <a:rPr lang="es-ES" sz="2000" dirty="0">
+                <a:solidFill>
+                  <a:srgbClr val="222222"/>
+                </a:solidFill>
+              </a:rPr>
+              <a:t>•  Todas las decisiones han sido supervisadas por mi.</a:t>
+            </a:r>
+          </a:p>
+          <a:p>
+            <a:pPr>
+              <a:spcAft>
+                <a:spcPts val="1800"/>
+              </a:spcAft>
+            </a:pPr>
+            <a:endParaRPr lang="es-ES" sz="2000" dirty="0">
+              <a:solidFill>
+                <a:srgbClr val="222222"/>
+              </a:solidFill>
+            </a:endParaRPr>
+          </a:p>
+          <a:p>
+            <a:pPr>
+              <a:spcAft>
+                <a:spcPts val="1800"/>
+              </a:spcAft>
+            </a:pPr>
+            <a:endParaRPr sz="2000" dirty="0">
+              <a:solidFill>
+                <a:srgbClr val="222222"/>
+              </a:solidFill>
+            </a:endParaRPr>
           </a:p>
         </p:txBody>
       </p:sp>
@@ -15616,7 +15638,7 @@
 </file>
 
 <file path=ppt/slides/slide9.xml><?xml version="1.0" encoding="utf-8"?>
-<p:sld xmlns:a="http://schemas.openxmlformats.org/drawingml/2006/main" xmlns:p="http://schemas.openxmlformats.org/presentationml/2006/main" xmlns:r="http://schemas.openxmlformats.org/officeDocument/2006/relationships">
+<p:sld xmlns:a="http://schemas.openxmlformats.org/drawingml/2006/main" xmlns:r="http://schemas.openxmlformats.org/officeDocument/2006/relationships" xmlns:p="http://schemas.openxmlformats.org/presentationml/2006/main">
   <p:cSld>
     <p:spTree>
       <p:nvGrpSpPr>
@@ -15624,7 +15646,14 @@
         <p:cNvGrpSpPr/>
         <p:nvPr/>
       </p:nvGrpSpPr>
-      <p:grpSpPr/>
+      <p:grpSpPr>
+        <a:xfrm>
+          <a:off x="0" y="0"/>
+          <a:ext cx="0" cy="0"/>
+          <a:chOff x="0" y="0"/>
+          <a:chExt cx="0" cy="0"/>
+        </a:xfrm>
+      </p:grpSpPr>
       <p:sp>
         <p:nvSpPr>
           <p:cNvPr id="2" name="Rectangle 1"/>
@@ -15790,7 +15819,7 @@
         <p:spPr>
           <a:xfrm>
             <a:off x="548640" y="1417320"/>
-            <a:ext cx="7863840" cy="461665"/>
+            <a:ext cx="10138410" cy="830997"/>
           </a:xfrm>
           <a:prstGeom prst="rect">
             <a:avLst/>
@@ -15811,83 +15840,6 @@
               </a:rPr>
               <a:t>Auditoría OWASP Top 10 (2021) y corrección vía SDD, no como añadido de última hora</a:t>
             </a:r>
-            <a:r>
-              <a:rPr sz="2400" b="1" dirty="0" err="1">
-                <a:solidFill>
-                  <a:srgbClr val="222222"/>
-                </a:solidFill>
-              </a:rPr>
-              <a:t/>
-            </a:r>
-            <a:r>
-              <a:rPr sz="2400" b="1" dirty="0">
-                <a:solidFill>
-                  <a:srgbClr val="222222"/>
-                </a:solidFill>
-              </a:rPr>
-              <a:t/>
-            </a:r>
-            <a:r>
-              <a:rPr sz="2400" b="1" dirty="0" err="1">
-                <a:solidFill>
-                  <a:srgbClr val="222222"/>
-                </a:solidFill>
-              </a:rPr>
-              <a:t/>
-            </a:r>
-            <a:r>
-              <a:rPr sz="2400" b="1" dirty="0">
-                <a:solidFill>
-                  <a:srgbClr val="222222"/>
-                </a:solidFill>
-              </a:rPr>
-              <a:t/>
-            </a:r>
-            <a:r>
-              <a:rPr sz="2400" b="1" dirty="0" err="1">
-                <a:solidFill>
-                  <a:srgbClr val="222222"/>
-                </a:solidFill>
-              </a:rPr>
-              <a:t/>
-            </a:r>
-            <a:r>
-              <a:rPr sz="2400" b="1" dirty="0">
-                <a:solidFill>
-                  <a:srgbClr val="222222"/>
-                </a:solidFill>
-              </a:rPr>
-              <a:t/>
-            </a:r>
-            <a:r>
-              <a:rPr sz="2400" b="1" dirty="0" err="1">
-                <a:solidFill>
-                  <a:srgbClr val="222222"/>
-                </a:solidFill>
-              </a:rPr>
-              <a:t/>
-            </a:r>
-            <a:r>
-              <a:rPr sz="2400" b="1" dirty="0">
-                <a:solidFill>
-                  <a:srgbClr val="222222"/>
-                </a:solidFill>
-              </a:rPr>
-              <a:t/>
-            </a:r>
-            <a:r>
-              <a:rPr sz="2400" b="1" dirty="0" err="1">
-                <a:solidFill>
-                  <a:srgbClr val="222222"/>
-                </a:solidFill>
-              </a:rPr>
-              <a:t/>
-            </a:r>
-            <a:endParaRPr sz="2400" b="1" dirty="0">
-              <a:solidFill>
-                <a:srgbClr val="222222"/>
-              </a:solidFill>
-            </a:endParaRPr>
           </a:p>
         </p:txBody>
       </p:sp>
@@ -15926,86 +15878,6 @@
               </a:rPr>
               <a:t>•  Auditoría OWASP Top 10: 16 hallazgos catalogados por severidad, 2 críticos (RBAC, reemplazo de configuración)</a:t>
             </a:r>
-            <a:r>
-              <a:rPr sz="2000" dirty="0" err="1">
-                <a:solidFill>
-                  <a:srgbClr val="222222"/>
-                </a:solidFill>
-              </a:rPr>
-              <a:t/>
-            </a:r>
-            <a:r>
-              <a:rPr sz="2000" dirty="0">
-                <a:solidFill>
-                  <a:srgbClr val="222222"/>
-                </a:solidFill>
-              </a:rPr>
-              <a:t/>
-            </a:r>
-            <a:r>
-              <a:rPr sz="2000" dirty="0" err="1">
-                <a:solidFill>
-                  <a:srgbClr val="222222"/>
-                </a:solidFill>
-              </a:rPr>
-              <a:t/>
-            </a:r>
-            <a:r>
-              <a:rPr sz="2000" dirty="0">
-                <a:solidFill>
-                  <a:srgbClr val="222222"/>
-                </a:solidFill>
-              </a:rPr>
-              <a:t/>
-            </a:r>
-            <a:r>
-              <a:rPr sz="2000" dirty="0" err="1">
-                <a:solidFill>
-                  <a:srgbClr val="222222"/>
-                </a:solidFill>
-              </a:rPr>
-              <a:t/>
-            </a:r>
-            <a:r>
-              <a:rPr sz="2000" dirty="0">
-                <a:solidFill>
-                  <a:srgbClr val="222222"/>
-                </a:solidFill>
-              </a:rPr>
-              <a:t/>
-            </a:r>
-            <a:r>
-              <a:rPr sz="2000" dirty="0" err="1">
-                <a:solidFill>
-                  <a:srgbClr val="222222"/>
-                </a:solidFill>
-              </a:rPr>
-              <a:t/>
-            </a:r>
-            <a:r>
-              <a:rPr sz="2000" dirty="0">
-                <a:solidFill>
-                  <a:srgbClr val="222222"/>
-                </a:solidFill>
-              </a:rPr>
-              <a:t/>
-            </a:r>
-            <a:r>
-              <a:rPr sz="2000" dirty="0" err="1">
-                <a:solidFill>
-                  <a:srgbClr val="222222"/>
-                </a:solidFill>
-              </a:rPr>
-              <a:t/>
-            </a:r>
-            <a:r>
-              <a:rPr sz="2000" dirty="0">
-                <a:solidFill>
-                  <a:srgbClr val="222222"/>
-                </a:solidFill>
-              </a:rPr>
-              <a:t/>
-            </a:r>
             <a:endParaRPr lang="es-ES" sz="2000" dirty="0">
               <a:solidFill>
                 <a:srgbClr val="222222"/>
@@ -16038,94 +15910,6 @@
               </a:rPr>
               <a:t>•  RBAC efectivo + salvaguarda de apply (confirmReplaceAll y preview) + checksum HMAC en snapshots</a:t>
             </a:r>
-            <a:r>
-              <a:rPr sz="2000" dirty="0" err="1">
-                <a:solidFill>
-                  <a:srgbClr val="222222"/>
-                </a:solidFill>
-              </a:rPr>
-              <a:t/>
-            </a:r>
-            <a:r>
-              <a:rPr sz="2000" dirty="0">
-                <a:solidFill>
-                  <a:srgbClr val="222222"/>
-                </a:solidFill>
-              </a:rPr>
-              <a:t/>
-            </a:r>
-            <a:r>
-              <a:rPr sz="2000" dirty="0" err="1">
-                <a:solidFill>
-                  <a:srgbClr val="222222"/>
-                </a:solidFill>
-              </a:rPr>
-              <a:t/>
-            </a:r>
-            <a:r>
-              <a:rPr sz="2000" dirty="0">
-                <a:solidFill>
-                  <a:srgbClr val="222222"/>
-                </a:solidFill>
-              </a:rPr>
-              <a:t/>
-            </a:r>
-            <a:r>
-              <a:rPr sz="2000" dirty="0" err="1">
-                <a:solidFill>
-                  <a:srgbClr val="222222"/>
-                </a:solidFill>
-              </a:rPr>
-              <a:t/>
-            </a:r>
-            <a:r>
-              <a:rPr sz="2000" dirty="0">
-                <a:solidFill>
-                  <a:srgbClr val="222222"/>
-                </a:solidFill>
-              </a:rPr>
-              <a:t/>
-            </a:r>
-            <a:r>
-              <a:rPr sz="2000" dirty="0" err="1">
-                <a:solidFill>
-                  <a:srgbClr val="222222"/>
-                </a:solidFill>
-              </a:rPr>
-              <a:t/>
-            </a:r>
-            <a:r>
-              <a:rPr sz="2000" dirty="0">
-                <a:solidFill>
-                  <a:srgbClr val="222222"/>
-                </a:solidFill>
-              </a:rPr>
-              <a:t/>
-            </a:r>
-            <a:r>
-              <a:rPr sz="2000" dirty="0" err="1">
-                <a:solidFill>
-                  <a:srgbClr val="222222"/>
-                </a:solidFill>
-              </a:rPr>
-              <a:t/>
-            </a:r>
-            <a:r>
-              <a:rPr sz="2000" dirty="0">
-                <a:solidFill>
-                  <a:srgbClr val="222222"/>
-                </a:solidFill>
-              </a:rPr>
-              <a:t/>
-            </a:r>
-            <a:r>
-              <a:rPr sz="2000" dirty="0" err="1">
-                <a:solidFill>
-                  <a:srgbClr val="222222"/>
-                </a:solidFill>
-              </a:rPr>
-              <a:t/>
-            </a:r>
             <a:endParaRPr lang="es-ES" sz="2000" dirty="0">
               <a:solidFill>
                 <a:srgbClr val="222222"/>
@@ -16157,86 +15941,6 @@
                 </a:solidFill>
               </a:rPr>
               <a:t>•  Mismo flujo SDD (TDD estricto) y verificación independiente antes de archivar: PASS, 0 críticos</a:t>
-            </a:r>
-            <a:r>
-              <a:rPr sz="2000" dirty="0" err="1">
-                <a:solidFill>
-                  <a:srgbClr val="222222"/>
-                </a:solidFill>
-              </a:rPr>
-              <a:t/>
-            </a:r>
-            <a:r>
-              <a:rPr sz="2000" dirty="0">
-                <a:solidFill>
-                  <a:srgbClr val="222222"/>
-                </a:solidFill>
-              </a:rPr>
-              <a:t/>
-            </a:r>
-            <a:r>
-              <a:rPr sz="2000" dirty="0" err="1">
-                <a:solidFill>
-                  <a:srgbClr val="222222"/>
-                </a:solidFill>
-              </a:rPr>
-              <a:t/>
-            </a:r>
-            <a:r>
-              <a:rPr sz="2000" dirty="0">
-                <a:solidFill>
-                  <a:srgbClr val="222222"/>
-                </a:solidFill>
-              </a:rPr>
-              <a:t/>
-            </a:r>
-            <a:r>
-              <a:rPr sz="2000" dirty="0" err="1">
-                <a:solidFill>
-                  <a:srgbClr val="222222"/>
-                </a:solidFill>
-              </a:rPr>
-              <a:t/>
-            </a:r>
-            <a:r>
-              <a:rPr sz="2000" dirty="0">
-                <a:solidFill>
-                  <a:srgbClr val="222222"/>
-                </a:solidFill>
-              </a:rPr>
-              <a:t/>
-            </a:r>
-            <a:r>
-              <a:rPr sz="2000" dirty="0" err="1">
-                <a:solidFill>
-                  <a:srgbClr val="222222"/>
-                </a:solidFill>
-              </a:rPr>
-              <a:t/>
-            </a:r>
-            <a:r>
-              <a:rPr sz="2000" dirty="0">
-                <a:solidFill>
-                  <a:srgbClr val="222222"/>
-                </a:solidFill>
-              </a:rPr>
-              <a:t/>
-            </a:r>
-            <a:r>
-              <a:rPr sz="2000" dirty="0" err="1">
-                <a:solidFill>
-                  <a:srgbClr val="222222"/>
-                </a:solidFill>
-              </a:rPr>
-              <a:t/>
-            </a:r>
-            <a:r>
-              <a:rPr sz="2000" dirty="0">
-                <a:solidFill>
-                  <a:srgbClr val="222222"/>
-                </a:solidFill>
-              </a:rPr>
-              <a:t/>
             </a:r>
           </a:p>
         </p:txBody>

</xml_diff>